<commit_message>
Fig. S-4 deck matches the SI window figure; Fig. 1 objects carry their colour bars
- make_figure_objects.py: Fig. S-4 objects are the SI window (256 px, grey phase, grey
  gradient, EdgeSAM (r=32) blue and MobileSAM (r=8) orange contours, 4x); the Fig. 1
  phase, z-score and volume objects are one image each with the colour bar and its
  printed values (limits / 0 / high-low), sized to the slide placeholders
- build_figures_pptx.py: slide 3 titles, legend, 20 um bars for a 36.89 um window and
  note; slides 1-2 placeholders with the combined aspect ratio, separate colour-bar
  number boxes removed; placeholders named after their object file
- SI Fig. S-4 caption and S-V paragraph back to the window / two-model wording

Co-Authored-By: Claude Opus 5.5 <noreply@anthropic.com>
Claude-Session: https://claude.ai/code/session_01VfeP9iXHsiwMyJPGSYpWbp
</commit_message>
<xml_diff>
--- a/artifacts/figures/pptx/Figures_revised.pptx
+++ b/artifacts/figures/pptx/Figures_revised.pptx
@@ -4564,7 +4564,7 @@
             </p:sp>
             <p:pic>
               <p:nvPicPr>
-                <p:cNvPr id="19" name="PLACEHOLDER" descr="p1_phase.png"/>
+                <p:cNvPr id="19" name="p1_phase.png" descr="p1_phase.png"/>
                 <p:cNvPicPr>
                   <a:picLocks noChangeAspect="1"/>
                 </p:cNvPicPr>
@@ -4578,32 +4578,8 @@
               </p:blipFill>
               <p:spPr>
                 <a:xfrm>
-                  <a:off x="334701" y="1686069"/>
-                  <a:ext cx="1228866" cy="1228866"/>
-                </a:xfrm>
-                <a:prstGeom prst="rect">
-                  <a:avLst/>
-                </a:prstGeom>
-              </p:spPr>
-            </p:pic>
-            <p:pic>
-              <p:nvPicPr>
-                <p:cNvPr id="1062" name="p1_phase_colorbar.png" descr="image.png"/>
-                <p:cNvPicPr>
-                  <a:picLocks noChangeAspect="1"/>
-                </p:cNvPicPr>
-                <p:nvPr/>
-              </p:nvPicPr>
-              <p:blipFill>
-                <a:blip r:embed="rId33"/>
-                <a:stretch>
-                  <a:fillRect/>
-                </a:stretch>
-              </p:blipFill>
-              <p:spPr>
-                <a:xfrm>
-                  <a:off x="1600143" y="1686069"/>
-                  <a:ext cx="54864" cy="1228866"/>
+                  <a:off x="334701" y="1686025"/>
+                  <a:ext cx="1512417" cy="1228953"/>
                 </a:xfrm>
                 <a:prstGeom prst="rect">
                   <a:avLst/>
@@ -6395,46 +6371,22 @@
             </mc:AlternateContent>
             <p:pic>
               <p:nvPicPr>
-                <p:cNvPr id="84" name="PLACEHOLDER" descr="p4_volume.png"/>
+                <p:cNvPr id="84" name="p4_volume.png" descr="p4_volume.png"/>
                 <p:cNvPicPr>
                   <a:picLocks noChangeAspect="1"/>
                 </p:cNvPicPr>
                 <p:nvPr/>
               </p:nvPicPr>
               <p:blipFill>
-                <a:blip r:embed="rId36"/>
+                <a:blip r:embed="rId34"/>
                 <a:stretch>
                   <a:fillRect/>
                 </a:stretch>
               </p:blipFill>
               <p:spPr>
                 <a:xfrm>
-                  <a:off x="10047284" y="1714288"/>
-                  <a:ext cx="1483046" cy="1483046"/>
-                </a:xfrm>
-                <a:prstGeom prst="rect">
-                  <a:avLst/>
-                </a:prstGeom>
-              </p:spPr>
-            </p:pic>
-            <p:pic>
-              <p:nvPicPr>
-                <p:cNvPr id="1064" name="p4_volume_colorbar.png" descr="image.png"/>
-                <p:cNvPicPr>
-                  <a:picLocks noChangeAspect="1"/>
-                </p:cNvPicPr>
-                <p:nvPr/>
-              </p:nvPicPr>
-              <p:blipFill>
-                <a:blip r:embed="rId37"/>
-                <a:stretch>
-                  <a:fillRect/>
-                </a:stretch>
-              </p:blipFill>
-              <p:spPr>
-                <a:xfrm>
-                  <a:off x="11566906" y="1714288"/>
-                  <a:ext cx="54864" cy="1483046"/>
+                  <a:off x="10047284" y="1714232"/>
+                  <a:ext cx="1766620" cy="1483156"/>
                 </a:xfrm>
                 <a:prstGeom prst="rect">
                   <a:avLst/>
@@ -6789,46 +6741,22 @@
             </p:sp>
             <p:pic>
               <p:nvPicPr>
-                <p:cNvPr id="24" name="PLACEHOLDER" descr="p2_norm.png"/>
+                <p:cNvPr id="24" name="p2_norm.png" descr="p2_norm.png"/>
                 <p:cNvPicPr>
                   <a:picLocks noChangeAspect="1"/>
                 </p:cNvPicPr>
                 <p:nvPr/>
               </p:nvPicPr>
               <p:blipFill>
-                <a:blip r:embed="rId34"/>
+                <a:blip r:embed="rId33"/>
                 <a:stretch>
                   <a:fillRect/>
                 </a:stretch>
               </p:blipFill>
               <p:spPr>
                 <a:xfrm>
-                  <a:off x="348482" y="4752671"/>
-                  <a:ext cx="1294490" cy="1294490"/>
-                </a:xfrm>
-                <a:prstGeom prst="rect">
-                  <a:avLst/>
-                </a:prstGeom>
-              </p:spPr>
-            </p:pic>
-            <p:pic>
-              <p:nvPicPr>
-                <p:cNvPr id="1063" name="p2_norm_colorbar.png" descr="image.png"/>
-                <p:cNvPicPr>
-                  <a:picLocks noChangeAspect="1"/>
-                </p:cNvPicPr>
-                <p:nvPr/>
-              </p:nvPicPr>
-              <p:blipFill>
-                <a:blip r:embed="rId35"/>
-                <a:stretch>
-                  <a:fillRect/>
-                </a:stretch>
-              </p:blipFill>
-              <p:spPr>
-                <a:xfrm>
-                  <a:off x="1679548" y="4752671"/>
-                  <a:ext cx="54864" cy="1294490"/>
+                  <a:off x="348482" y="4792297"/>
+                  <a:ext cx="1498701" cy="1215237"/>
                 </a:xfrm>
                 <a:prstGeom prst="rect">
                   <a:avLst/>
@@ -8084,14 +8012,14 @@
             </p:sp>
             <p:pic>
               <p:nvPicPr>
-                <p:cNvPr id="52" name="PLACEHOLDER" descr="p3_mask.png"/>
+                <p:cNvPr id="52" name="p3_mask.png" descr="p3_mask.png"/>
                 <p:cNvPicPr>
                   <a:picLocks noChangeAspect="1"/>
                 </p:cNvPicPr>
                 <p:nvPr/>
               </p:nvPicPr>
               <p:blipFill>
-                <a:blip r:embed="rId38"/>
+                <a:blip r:embed="rId35"/>
                 <a:stretch>
                   <a:fillRect/>
                 </a:stretch>
@@ -12525,425 +12453,6 @@
             </p:cxnSp>
             <p:sp>
               <p:nvSpPr>
-                <p:cNvPr id="161" name="TextBox 160">
-                  <a:extLst>
-                    <a:ext uri="{FF2B5EF4-FFF2-40B4-BE49-F238E27FC236}">
-                      <a16:creationId xmlns:a16="http://schemas.microsoft.com/office/drawing/2014/main" id="{4774F573-2F67-40EB-892A-930121E3E836}"/>
-                    </a:ext>
-                  </a:extLst>
-                </p:cNvPr>
-                <p:cNvSpPr txBox="1"/>
-                <p:nvPr/>
-              </p:nvSpPr>
-              <p:spPr>
-                <a:xfrm>
-                  <a:off x="1634370" y="1663573"/>
-                  <a:ext cx="164472" cy="123111"/>
-                </a:xfrm>
-                <a:prstGeom prst="rect">
-                  <a:avLst/>
-                </a:prstGeom>
-                <a:solidFill>
-                  <a:schemeClr val="bg1"/>
-                </a:solidFill>
-              </p:spPr>
-              <p:txBody>
-                <a:bodyPr wrap="square" lIns="0" tIns="0" rIns="0" bIns="0" anchor="ctr">
-                  <a:spAutoFit/>
-                </a:bodyPr>
-                <a:lstStyle/>
-                <a:p>
-                  <a:pPr algn="ctr"/>
-                  <a:r>
-                    <a:rPr lang="en-US" sz="800" dirty="0">
-                      <a:ln>
-                        <a:solidFill>
-                          <a:schemeClr val="accent1">
-                            <a:alpha val="0"/>
-                          </a:schemeClr>
-                        </a:solidFill>
-                      </a:ln>
-                      <a:solidFill>
-                        <a:schemeClr val="tx1">
-                          <a:lumMod val="75000"/>
-                          <a:lumOff val="25000"/>
-                        </a:schemeClr>
-                      </a:solidFill>
-                      <a:latin typeface="Arial"/>
-                    </a:rPr>
-                    <a:t>6.3</a:t>
-                  </a:r>
-                </a:p>
-              </p:txBody>
-            </p:sp>
-            <p:sp>
-              <p:nvSpPr>
-                <p:cNvPr id="162" name="TextBox 161">
-                  <a:extLst>
-                    <a:ext uri="{FF2B5EF4-FFF2-40B4-BE49-F238E27FC236}">
-                      <a16:creationId xmlns:a16="http://schemas.microsoft.com/office/drawing/2014/main" id="{CFFB8879-80F0-4D8B-A9FB-54F5D53E0E1B}"/>
-                    </a:ext>
-                  </a:extLst>
-                </p:cNvPr>
-                <p:cNvSpPr txBox="1"/>
-                <p:nvPr/>
-              </p:nvSpPr>
-              <p:spPr>
-                <a:xfrm>
-                  <a:off x="1646257" y="2588172"/>
-                  <a:ext cx="119846" cy="123111"/>
-                </a:xfrm>
-                <a:prstGeom prst="rect">
-                  <a:avLst/>
-                </a:prstGeom>
-                <a:solidFill>
-                  <a:schemeClr val="bg1"/>
-                </a:solidFill>
-              </p:spPr>
-              <p:txBody>
-                <a:bodyPr wrap="square" lIns="0" tIns="0" rIns="0" bIns="0" anchor="ctr">
-                  <a:spAutoFit/>
-                </a:bodyPr>
-                <a:lstStyle/>
-                <a:p>
-                  <a:r>
-                    <a:rPr lang="en-US" sz="800" dirty="0">
-                      <a:ln>
-                        <a:solidFill>
-                          <a:schemeClr val="accent1">
-                            <a:alpha val="0"/>
-                          </a:schemeClr>
-                        </a:solidFill>
-                      </a:ln>
-                      <a:solidFill>
-                        <a:schemeClr val="tx1">
-                          <a:lumMod val="75000"/>
-                          <a:lumOff val="25000"/>
-                        </a:schemeClr>
-                      </a:solidFill>
-                      <a:latin typeface="Arial"/>
-                    </a:rPr>
-                    <a:t>0</a:t>
-                  </a:r>
-                </a:p>
-              </p:txBody>
-            </p:sp>
-            <p:sp>
-              <p:nvSpPr>
-                <p:cNvPr id="163" name="TextBox 162">
-                  <a:extLst>
-                    <a:ext uri="{FF2B5EF4-FFF2-40B4-BE49-F238E27FC236}">
-                      <a16:creationId xmlns:a16="http://schemas.microsoft.com/office/drawing/2014/main" id="{3DF9B772-840C-4D63-8725-9FD056B6BCC5}"/>
-                    </a:ext>
-                  </a:extLst>
-                </p:cNvPr>
-                <p:cNvSpPr txBox="1"/>
-                <p:nvPr/>
-              </p:nvSpPr>
-              <p:spPr>
-                <a:xfrm>
-                  <a:off x="1635529" y="2783344"/>
-                  <a:ext cx="203466" cy="123111"/>
-                </a:xfrm>
-                <a:prstGeom prst="rect">
-                  <a:avLst/>
-                </a:prstGeom>
-                <a:solidFill>
-                  <a:schemeClr val="bg1"/>
-                </a:solidFill>
-              </p:spPr>
-              <p:txBody>
-                <a:bodyPr wrap="square" lIns="0" tIns="0" rIns="0" bIns="0" anchor="ctr">
-                  <a:spAutoFit/>
-                </a:bodyPr>
-                <a:lstStyle/>
-                <a:p>
-                  <a:r>
-                    <a:rPr lang="en-US" sz="800" dirty="0">
-                      <a:ln>
-                        <a:solidFill>
-                          <a:schemeClr val="accent1">
-                            <a:alpha val="0"/>
-                          </a:schemeClr>
-                        </a:solidFill>
-                      </a:ln>
-                      <a:solidFill>
-                        <a:schemeClr val="tx1">
-                          <a:lumMod val="75000"/>
-                          <a:lumOff val="25000"/>
-                        </a:schemeClr>
-                      </a:solidFill>
-                      <a:latin typeface="Arial"/>
-                    </a:rPr>
-                    <a:t>-2.5</a:t>
-                  </a:r>
-                </a:p>
-              </p:txBody>
-            </p:sp>
-            <p:sp>
-              <p:nvSpPr>
-                <p:cNvPr id="167" name="TextBox 166">
-                  <a:extLst>
-                    <a:ext uri="{FF2B5EF4-FFF2-40B4-BE49-F238E27FC236}">
-                      <a16:creationId xmlns:a16="http://schemas.microsoft.com/office/drawing/2014/main" id="{FFA19812-E088-41BF-A0A3-0CCF0355703A}"/>
-                    </a:ext>
-                  </a:extLst>
-                </p:cNvPr>
-                <p:cNvSpPr txBox="1"/>
-                <p:nvPr/>
-              </p:nvSpPr>
-              <p:spPr>
-                <a:xfrm>
-                  <a:off x="1714308" y="4734252"/>
-                  <a:ext cx="106654" cy="123111"/>
-                </a:xfrm>
-                <a:prstGeom prst="rect">
-                  <a:avLst/>
-                </a:prstGeom>
-                <a:solidFill>
-                  <a:schemeClr val="bg1"/>
-                </a:solidFill>
-              </p:spPr>
-              <p:txBody>
-                <a:bodyPr wrap="square" lIns="0" tIns="0" rIns="0" bIns="0" anchor="ctr">
-                  <a:spAutoFit/>
-                </a:bodyPr>
-                <a:lstStyle/>
-                <a:p>
-                  <a:r>
-                    <a:rPr lang="en-US" sz="800" dirty="0">
-                      <a:ln>
-                        <a:solidFill>
-                          <a:schemeClr val="accent1">
-                            <a:alpha val="0"/>
-                          </a:schemeClr>
-                        </a:solidFill>
-                      </a:ln>
-                      <a:solidFill>
-                        <a:schemeClr val="tx1">
-                          <a:lumMod val="75000"/>
-                          <a:lumOff val="25000"/>
-                        </a:schemeClr>
-                      </a:solidFill>
-                      <a:latin typeface="Arial"/>
-                    </a:rPr>
-                    <a:t>3</a:t>
-                  </a:r>
-                </a:p>
-              </p:txBody>
-            </p:sp>
-            <p:sp>
-              <p:nvSpPr>
-                <p:cNvPr id="168" name="TextBox 167">
-                  <a:extLst>
-                    <a:ext uri="{FF2B5EF4-FFF2-40B4-BE49-F238E27FC236}">
-                      <a16:creationId xmlns:a16="http://schemas.microsoft.com/office/drawing/2014/main" id="{744BEFB7-A007-4360-8087-DB85F6D1406B}"/>
-                    </a:ext>
-                  </a:extLst>
-                </p:cNvPr>
-                <p:cNvSpPr txBox="1"/>
-                <p:nvPr/>
-              </p:nvSpPr>
-              <p:spPr>
-                <a:xfrm>
-                  <a:off x="1714308" y="5328939"/>
-                  <a:ext cx="106654" cy="123111"/>
-                </a:xfrm>
-                <a:prstGeom prst="rect">
-                  <a:avLst/>
-                </a:prstGeom>
-                <a:solidFill>
-                  <a:schemeClr val="bg1"/>
-                </a:solidFill>
-              </p:spPr>
-              <p:txBody>
-                <a:bodyPr wrap="square" lIns="0" tIns="0" rIns="0" bIns="0" anchor="ctr">
-                  <a:spAutoFit/>
-                </a:bodyPr>
-                <a:lstStyle/>
-                <a:p>
-                  <a:r>
-                    <a:rPr lang="en-US" sz="800" dirty="0">
-                      <a:ln>
-                        <a:solidFill>
-                          <a:schemeClr val="accent1">
-                            <a:alpha val="0"/>
-                          </a:schemeClr>
-                        </a:solidFill>
-                      </a:ln>
-                      <a:solidFill>
-                        <a:schemeClr val="tx1">
-                          <a:lumMod val="75000"/>
-                          <a:lumOff val="25000"/>
-                        </a:schemeClr>
-                      </a:solidFill>
-                      <a:latin typeface="Arial"/>
-                    </a:rPr>
-                    <a:t>0</a:t>
-                  </a:r>
-                </a:p>
-              </p:txBody>
-            </p:sp>
-            <p:sp>
-              <p:nvSpPr>
-                <p:cNvPr id="176" name="TextBox 175">
-                  <a:extLst>
-                    <a:ext uri="{FF2B5EF4-FFF2-40B4-BE49-F238E27FC236}">
-                      <a16:creationId xmlns:a16="http://schemas.microsoft.com/office/drawing/2014/main" id="{73CE3E4F-E638-4887-9E15-87B4B126A98B}"/>
-                    </a:ext>
-                  </a:extLst>
-                </p:cNvPr>
-                <p:cNvSpPr txBox="1"/>
-                <p:nvPr/>
-              </p:nvSpPr>
-              <p:spPr>
-                <a:xfrm>
-                  <a:off x="1714308" y="5913541"/>
-                  <a:ext cx="106654" cy="123111"/>
-                </a:xfrm>
-                <a:prstGeom prst="rect">
-                  <a:avLst/>
-                </a:prstGeom>
-                <a:solidFill>
-                  <a:schemeClr val="bg1"/>
-                </a:solidFill>
-              </p:spPr>
-              <p:txBody>
-                <a:bodyPr wrap="square" lIns="0" tIns="0" rIns="0" bIns="0" anchor="ctr">
-                  <a:spAutoFit/>
-                </a:bodyPr>
-                <a:lstStyle/>
-                <a:p>
-                  <a:r>
-                    <a:rPr lang="en-US" sz="800" dirty="0">
-                      <a:ln>
-                        <a:solidFill>
-                          <a:schemeClr val="accent1">
-                            <a:alpha val="0"/>
-                          </a:schemeClr>
-                        </a:solidFill>
-                      </a:ln>
-                      <a:solidFill>
-                        <a:schemeClr val="tx1">
-                          <a:lumMod val="75000"/>
-                          <a:lumOff val="25000"/>
-                        </a:schemeClr>
-                      </a:solidFill>
-                      <a:latin typeface="Arial"/>
-                    </a:rPr>
-                    <a:t>-3</a:t>
-                  </a:r>
-                </a:p>
-              </p:txBody>
-            </p:sp>
-            <p:sp>
-              <p:nvSpPr>
-                <p:cNvPr id="177" name="TextBox 176">
-                  <a:extLst>
-                    <a:ext uri="{FF2B5EF4-FFF2-40B4-BE49-F238E27FC236}">
-                      <a16:creationId xmlns:a16="http://schemas.microsoft.com/office/drawing/2014/main" id="{9B275737-7EFF-4A42-A06F-6320EAD916AF}"/>
-                    </a:ext>
-                  </a:extLst>
-                </p:cNvPr>
-                <p:cNvSpPr txBox="1"/>
-                <p:nvPr/>
-              </p:nvSpPr>
-              <p:spPr>
-                <a:xfrm>
-                  <a:off x="11609081" y="1709121"/>
-                  <a:ext cx="248081" cy="123111"/>
-                </a:xfrm>
-                <a:prstGeom prst="rect">
-                  <a:avLst/>
-                </a:prstGeom>
-                <a:solidFill>
-                  <a:schemeClr val="bg1"/>
-                </a:solidFill>
-              </p:spPr>
-              <p:txBody>
-                <a:bodyPr wrap="square" lIns="0" tIns="0" rIns="0" bIns="0" anchor="ctr">
-                  <a:spAutoFit/>
-                </a:bodyPr>
-                <a:lstStyle/>
-                <a:p>
-                  <a:pPr algn="ctr"/>
-                  <a:r>
-                    <a:rPr lang="en-US" sz="800" dirty="0">
-                      <a:ln>
-                        <a:solidFill>
-                          <a:schemeClr val="accent1">
-                            <a:alpha val="0"/>
-                          </a:schemeClr>
-                        </a:solidFill>
-                      </a:ln>
-                      <a:solidFill>
-                        <a:schemeClr val="tx1">
-                          <a:lumMod val="75000"/>
-                          <a:lumOff val="25000"/>
-                        </a:schemeClr>
-                      </a:solidFill>
-                      <a:latin typeface="Arial"/>
-                    </a:rPr>
-                    <a:t>high</a:t>
-                  </a:r>
-                </a:p>
-              </p:txBody>
-            </p:sp>
-            <p:sp>
-              <p:nvSpPr>
-                <p:cNvPr id="178" name="TextBox 177">
-                  <a:extLst>
-                    <a:ext uri="{FF2B5EF4-FFF2-40B4-BE49-F238E27FC236}">
-                      <a16:creationId xmlns:a16="http://schemas.microsoft.com/office/drawing/2014/main" id="{8A144EB8-19D3-4B32-A5B3-9F9D01AB7101}"/>
-                    </a:ext>
-                  </a:extLst>
-                </p:cNvPr>
-                <p:cNvSpPr txBox="1"/>
-                <p:nvPr/>
-              </p:nvSpPr>
-              <p:spPr>
-                <a:xfrm>
-                  <a:off x="11604933" y="3071594"/>
-                  <a:ext cx="210693" cy="123111"/>
-                </a:xfrm>
-                <a:prstGeom prst="rect">
-                  <a:avLst/>
-                </a:prstGeom>
-                <a:solidFill>
-                  <a:schemeClr val="bg1"/>
-                </a:solidFill>
-              </p:spPr>
-              <p:txBody>
-                <a:bodyPr wrap="square" lIns="0" tIns="0" rIns="0" bIns="0" anchor="ctr">
-                  <a:spAutoFit/>
-                </a:bodyPr>
-                <a:lstStyle/>
-                <a:p>
-                  <a:pPr algn="ctr"/>
-                  <a:r>
-                    <a:rPr lang="en-US" sz="800" dirty="0">
-                      <a:ln>
-                        <a:solidFill>
-                          <a:schemeClr val="accent1">
-                            <a:alpha val="0"/>
-                          </a:schemeClr>
-                        </a:solidFill>
-                      </a:ln>
-                      <a:solidFill>
-                        <a:schemeClr val="tx1">
-                          <a:lumMod val="75000"/>
-                          <a:lumOff val="25000"/>
-                        </a:schemeClr>
-                      </a:solidFill>
-                      <a:latin typeface="Arial"/>
-                    </a:rPr>
-                    <a:t>low</a:t>
-                  </a:r>
-                </a:p>
-              </p:txBody>
-            </p:sp>
-            <p:sp>
-              <p:nvSpPr>
                 <p:cNvPr id="37" name="TextBox 36"/>
                 <p:cNvSpPr txBox="1"/>
                 <p:nvPr/>
@@ -13111,7 +12620,7 @@
       </p:grpSpPr>
       <p:pic>
         <p:nvPicPr>
-          <p:cNvPr id="46" name="PLACEHOLDER" descr="p3_mask.png">
+          <p:cNvPr id="46" name="p3_mask.png" descr="p3_mask.png">
             <a:extLst>
               <a:ext uri="{FF2B5EF4-FFF2-40B4-BE49-F238E27FC236}">
                 <a16:creationId xmlns:a16="http://schemas.microsoft.com/office/drawing/2014/main" id="{3594289F-97B5-F2F2-6116-5B192D6BDF0B}"/>
@@ -13124,7 +12633,7 @@
           <p:nvPr/>
         </p:nvPicPr>
         <p:blipFill>
-          <a:blip r:embed="rId12"/>
+          <a:blip r:embed="rId9"/>
           <a:stretch>
             <a:fillRect/>
           </a:stretch>
@@ -13185,7 +12694,7 @@
       </p:sp>
       <p:pic>
         <p:nvPicPr>
-          <p:cNvPr id="51" name="PLACEHOLDER" descr="p1_phase.png">
+          <p:cNvPr id="51" name="p1_phase.png" descr="p1_phase.png">
             <a:extLst>
               <a:ext uri="{FF2B5EF4-FFF2-40B4-BE49-F238E27FC236}">
                 <a16:creationId xmlns:a16="http://schemas.microsoft.com/office/drawing/2014/main" id="{D25C8E7F-326E-A51F-AB01-D0066470554A}"/>
@@ -13205,8 +12714,8 @@
         </p:blipFill>
         <p:spPr>
           <a:xfrm>
-            <a:off x="411154" y="1477732"/>
-            <a:ext cx="1228866" cy="1228866"/>
+            <a:off x="411154" y="1477688"/>
+            <a:ext cx="1512417" cy="1228953"/>
           </a:xfrm>
           <a:prstGeom prst="rect">
             <a:avLst/>
@@ -13215,40 +12724,10 @@
       </p:pic>
       <p:pic>
         <p:nvPicPr>
-          <p:cNvPr id="69" name="PLACEHOLDER" descr="p4_volume.png">
+          <p:cNvPr id="69" name="p4_volume.png" descr="p4_volume.png">
             <a:extLst>
               <a:ext uri="{FF2B5EF4-FFF2-40B4-BE49-F238E27FC236}">
                 <a16:creationId xmlns:a16="http://schemas.microsoft.com/office/drawing/2014/main" id="{520A6665-B799-F6A8-AEAC-9A58969EF8AD}"/>
-              </a:ext>
-            </a:extLst>
-          </p:cNvPr>
-          <p:cNvPicPr>
-            <a:picLocks noChangeAspect="1"/>
-          </p:cNvPicPr>
-          <p:nvPr/>
-        </p:nvPicPr>
-        <p:blipFill>
-          <a:blip r:embed="rId10"/>
-          <a:stretch>
-            <a:fillRect/>
-          </a:stretch>
-        </p:blipFill>
-        <p:spPr>
-          <a:xfrm>
-            <a:off x="10024005" y="1727452"/>
-            <a:ext cx="1483046" cy="1483046"/>
-          </a:xfrm>
-          <a:prstGeom prst="rect">
-            <a:avLst/>
-          </a:prstGeom>
-        </p:spPr>
-      </p:pic>
-      <p:pic>
-        <p:nvPicPr>
-          <p:cNvPr id="71" name="PLACEHOLDER" descr="p2_norm.png">
-            <a:extLst>
-              <a:ext uri="{FF2B5EF4-FFF2-40B4-BE49-F238E27FC236}">
-                <a16:creationId xmlns:a16="http://schemas.microsoft.com/office/drawing/2014/main" id="{01530DDB-B2CF-5D94-61C5-7B40A5E0475E}"/>
               </a:ext>
             </a:extLst>
           </p:cNvPr>
@@ -13265,8 +12744,8 @@
         </p:blipFill>
         <p:spPr>
           <a:xfrm>
-            <a:off x="325203" y="4765835"/>
-            <a:ext cx="1294490" cy="1294490"/>
+            <a:off x="10024005" y="1727396"/>
+            <a:ext cx="1766620" cy="1483156"/>
           </a:xfrm>
           <a:prstGeom prst="rect">
             <a:avLst/>
@@ -13275,7 +12754,13 @@
       </p:pic>
       <p:pic>
         <p:nvPicPr>
-          <p:cNvPr id="72" name="p1_phase_colorbar.png" descr="image.png"/>
+          <p:cNvPr id="71" name="p2_norm.png" descr="p2_norm.png">
+            <a:extLst>
+              <a:ext uri="{FF2B5EF4-FFF2-40B4-BE49-F238E27FC236}">
+                <a16:creationId xmlns:a16="http://schemas.microsoft.com/office/drawing/2014/main" id="{01530DDB-B2CF-5D94-61C5-7B40A5E0475E}"/>
+              </a:ext>
+            </a:extLst>
+          </p:cNvPr>
           <p:cNvPicPr>
             <a:picLocks noChangeAspect="1"/>
           </p:cNvPicPr>
@@ -13289,56 +12774,8 @@
         </p:blipFill>
         <p:spPr>
           <a:xfrm>
-            <a:off x="1676596" y="1477732"/>
-            <a:ext cx="54864" cy="1228866"/>
-          </a:xfrm>
-          <a:prstGeom prst="rect">
-            <a:avLst/>
-          </a:prstGeom>
-        </p:spPr>
-      </p:pic>
-      <p:pic>
-        <p:nvPicPr>
-          <p:cNvPr id="73" name="p2_norm_colorbar.png" descr="image.png"/>
-          <p:cNvPicPr>
-            <a:picLocks noChangeAspect="1"/>
-          </p:cNvPicPr>
-          <p:nvPr/>
-        </p:nvPicPr>
-        <p:blipFill>
-          <a:blip r:embed="rId9"/>
-          <a:stretch>
-            <a:fillRect/>
-          </a:stretch>
-        </p:blipFill>
-        <p:spPr>
-          <a:xfrm>
-            <a:off x="1656269" y="4765835"/>
-            <a:ext cx="54864" cy="1294490"/>
-          </a:xfrm>
-          <a:prstGeom prst="rect">
-            <a:avLst/>
-          </a:prstGeom>
-        </p:spPr>
-      </p:pic>
-      <p:pic>
-        <p:nvPicPr>
-          <p:cNvPr id="74" name="p4_volume_colorbar.png" descr="image.png"/>
-          <p:cNvPicPr>
-            <a:picLocks noChangeAspect="1"/>
-          </p:cNvPicPr>
-          <p:nvPr/>
-        </p:nvPicPr>
-        <p:blipFill>
-          <a:blip r:embed="rId11"/>
-          <a:stretch>
-            <a:fillRect/>
-          </a:stretch>
-        </p:blipFill>
-        <p:spPr>
-          <a:xfrm>
-            <a:off x="11543626" y="1727452"/>
-            <a:ext cx="54864" cy="1483046"/>
+            <a:off x="325203" y="4805461"/>
+            <a:ext cx="1498701" cy="1215237"/>
           </a:xfrm>
           <a:prstGeom prst="rect">
             <a:avLst/>
@@ -13347,7 +12784,7 @@
       </p:pic>
       <p:sp>
         <p:nvSpPr>
-          <p:cNvPr id="75" name="TextBox 74"/>
+          <p:cNvPr id="72" name="TextBox 71"/>
           <p:cNvSpPr txBox="1"/>
           <p:nvPr/>
         </p:nvSpPr>
@@ -13375,7 +12812,7 @@
                 </a:solidFill>
                 <a:latin typeface="Arial"/>
               </a:rPr>
-              <a:t>Objects written by artifacts/code/make_figure_objects.py to artifacts/figures/objects/Fig1/. Colour-bar limits are listed in objects.json (Fig1); update the numbers next to the colour bars on slide 1.</a:t>
+              <a:t>Objects written by artifacts/code/make_figure_objects.py to artifacts/figures/objects/Fig1/. The phase, z-score and volume objects include their colour bar and its values (limits also in objects.json).</a:t>
             </a:r>
           </a:p>
         </p:txBody>
@@ -13506,7 +12943,7 @@
         </p:sp>
         <p:pic>
           <p:nvPicPr>
-            <p:cNvPr id="3" name="PLACEHOLDER" descr="fig07_p1_raw_phase.png"/>
+            <p:cNvPr id="3" name="p1_phase.png" descr="fig07_p1_raw_phase.png"/>
             <p:cNvPicPr>
               <a:picLocks noChangeAspect="1"/>
             </p:cNvPicPr>
@@ -13537,7 +12974,7 @@
           <p:spPr>
             <a:xfrm>
               <a:off x="1454921" y="4876501"/>
-              <a:ext cx="554156" cy="54864"/>
+              <a:ext cx="1662470" cy="54864"/>
             </a:xfrm>
             <a:prstGeom prst="rect">
               <a:avLst/>
@@ -13580,8 +13017,8 @@
           </p:nvSpPr>
           <p:spPr>
             <a:xfrm>
-              <a:off x="1441067" y="4644853"/>
-              <a:ext cx="581864" cy="213360"/>
+              <a:off x="1409201" y="4644853"/>
+              <a:ext cx="1753910" cy="213360"/>
             </a:xfrm>
             <a:prstGeom prst="rect">
               <a:avLst/>
@@ -13644,7 +13081,7 @@
         </p:sp>
         <p:pic>
           <p:nvPicPr>
-            <p:cNvPr id="7" name="PLACEHOLDER" descr="fig07_p2_phase_gradient.png"/>
+            <p:cNvPr id="7" name="p2_gradient.png" descr="fig07_p2_phase_gradient.png"/>
             <p:cNvPicPr>
               <a:picLocks noChangeAspect="1"/>
             </p:cNvPicPr>
@@ -13675,7 +13112,7 @@
           <p:spPr>
             <a:xfrm>
               <a:off x="4700791" y="4876501"/>
-              <a:ext cx="554156" cy="54864"/>
+              <a:ext cx="1662470" cy="54864"/>
             </a:xfrm>
             <a:prstGeom prst="rect">
               <a:avLst/>
@@ -13718,8 +13155,8 @@
           </p:nvSpPr>
           <p:spPr>
             <a:xfrm>
-              <a:off x="4686937" y="4644853"/>
-              <a:ext cx="581864" cy="213360"/>
+              <a:off x="4655071" y="4644853"/>
+              <a:ext cx="1753910" cy="213360"/>
             </a:xfrm>
             <a:prstGeom prst="rect">
               <a:avLst/>
@@ -13782,7 +13219,7 @@
         </p:sp>
         <p:pic>
           <p:nvPicPr>
-            <p:cNvPr id="11" name="PLACEHOLDER" descr="fig07_p3_edgesam_contour.png"/>
+            <p:cNvPr id="11" name="p3_contours.png" descr="fig07_p3_edgesam_contour.png"/>
             <p:cNvPicPr>
               <a:picLocks noChangeAspect="1"/>
             </p:cNvPicPr>
@@ -13813,7 +13250,7 @@
           <p:spPr>
             <a:xfrm>
               <a:off x="7946660" y="4876501"/>
-              <a:ext cx="554156" cy="54864"/>
+              <a:ext cx="1662470" cy="54864"/>
             </a:xfrm>
             <a:prstGeom prst="rect">
               <a:avLst/>
@@ -13856,8 +13293,8 @@
           </p:nvSpPr>
           <p:spPr>
             <a:xfrm>
-              <a:off x="7932806" y="4644853"/>
-              <a:ext cx="581864" cy="213360"/>
+              <a:off x="7900940" y="4644853"/>
+              <a:ext cx="1753910" cy="213360"/>
             </a:xfrm>
             <a:prstGeom prst="rect">
               <a:avLst/>
@@ -13913,7 +13350,209 @@
                   </a:solidFill>
                   <a:latin typeface="Arial"/>
                 </a:rPr>
-                <a:t>EdgeSAM (r=32) contours</a:t>
+                <a:t>Predicted contours</a:t>
+              </a:r>
+            </a:p>
+          </p:txBody>
+        </p:sp>
+        <p:sp>
+          <p:nvSpPr>
+            <p:cNvPr id="18" name="Legend box"/>
+            <p:cNvSpPr/>
+            <p:nvPr/>
+          </p:nvSpPr>
+          <p:spPr>
+            <a:xfrm>
+              <a:off x="9393737" y="2066966"/>
+              <a:ext cx="1417320" cy="420624"/>
+            </a:xfrm>
+            <a:prstGeom prst="rect">
+              <a:avLst/>
+            </a:prstGeom>
+            <a:solidFill>
+              <a:srgbClr val="FFFFFF"/>
+            </a:solidFill>
+            <a:ln w="6350">
+              <a:solidFill>
+                <a:srgbClr val="BFBFBF"/>
+              </a:solidFill>
+            </a:ln>
+            <a:effectLst/>
+          </p:spPr>
+          <p:style>
+            <a:lnRef idx="1">
+              <a:schemeClr val="accent1"/>
+            </a:lnRef>
+            <a:fillRef idx="3">
+              <a:schemeClr val="accent1"/>
+            </a:fillRef>
+            <a:effectRef idx="2">
+              <a:schemeClr val="accent1"/>
+            </a:effectRef>
+            <a:fontRef idx="minor">
+              <a:schemeClr val="lt1"/>
+            </a:fontRef>
+          </p:style>
+          <p:txBody>
+            <a:bodyPr rtlCol="0" anchor="ctr"/>
+            <a:lstStyle/>
+            <a:p>
+              <a:pPr algn="ctr"/>
+            </a:p>
+          </p:txBody>
+        </p:sp>
+        <p:sp>
+          <p:nvSpPr>
+            <p:cNvPr id="19" name="Legend EdgeSAM (r=32)"/>
+            <p:cNvSpPr/>
+            <p:nvPr/>
+          </p:nvSpPr>
+          <p:spPr>
+            <a:xfrm>
+              <a:off x="9466889" y="2149262"/>
+              <a:ext cx="201168" cy="100584"/>
+            </a:xfrm>
+            <a:prstGeom prst="rect">
+              <a:avLst/>
+            </a:prstGeom>
+            <a:solidFill>
+              <a:srgbClr val="2A78D6"/>
+            </a:solidFill>
+            <a:ln>
+              <a:noFill/>
+            </a:ln>
+            <a:effectLst/>
+          </p:spPr>
+          <p:style>
+            <a:lnRef idx="1">
+              <a:schemeClr val="accent1"/>
+            </a:lnRef>
+            <a:fillRef idx="3">
+              <a:schemeClr val="accent1"/>
+            </a:fillRef>
+            <a:effectRef idx="2">
+              <a:schemeClr val="accent1"/>
+            </a:effectRef>
+            <a:fontRef idx="minor">
+              <a:schemeClr val="lt1"/>
+            </a:fontRef>
+          </p:style>
+          <p:txBody>
+            <a:bodyPr rtlCol="0" anchor="ctr"/>
+            <a:lstStyle/>
+            <a:p>
+              <a:pPr algn="ctr"/>
+            </a:p>
+          </p:txBody>
+        </p:sp>
+        <p:sp>
+          <p:nvSpPr>
+            <p:cNvPr id="20" name="TextBox 19"/>
+            <p:cNvSpPr txBox="1"/>
+            <p:nvPr/>
+          </p:nvSpPr>
+          <p:spPr>
+            <a:xfrm>
+              <a:off x="9722920" y="2121830"/>
+              <a:ext cx="1051560" cy="155448"/>
+            </a:xfrm>
+            <a:prstGeom prst="rect">
+              <a:avLst/>
+            </a:prstGeom>
+            <a:noFill/>
+          </p:spPr>
+          <p:txBody>
+            <a:bodyPr wrap="none" lIns="0" rIns="0" tIns="0" bIns="0" anchor="ctr">
+              <a:spAutoFit/>
+            </a:bodyPr>
+            <a:lstStyle/>
+            <a:p>
+              <a:r>
+                <a:rPr sz="1000">
+                  <a:solidFill>
+                    <a:srgbClr val="000000"/>
+                  </a:solidFill>
+                  <a:latin typeface="Arial"/>
+                </a:rPr>
+                <a:t>EdgeSAM (r=32)</a:t>
+              </a:r>
+            </a:p>
+          </p:txBody>
+        </p:sp>
+        <p:sp>
+          <p:nvSpPr>
+            <p:cNvPr id="21" name="Legend MobileSAM (r=8)"/>
+            <p:cNvSpPr/>
+            <p:nvPr/>
+          </p:nvSpPr>
+          <p:spPr>
+            <a:xfrm>
+              <a:off x="9466889" y="2313854"/>
+              <a:ext cx="201168" cy="100584"/>
+            </a:xfrm>
+            <a:prstGeom prst="rect">
+              <a:avLst/>
+            </a:prstGeom>
+            <a:solidFill>
+              <a:srgbClr val="EB6834"/>
+            </a:solidFill>
+            <a:ln>
+              <a:noFill/>
+            </a:ln>
+            <a:effectLst/>
+          </p:spPr>
+          <p:style>
+            <a:lnRef idx="1">
+              <a:schemeClr val="accent1"/>
+            </a:lnRef>
+            <a:fillRef idx="3">
+              <a:schemeClr val="accent1"/>
+            </a:fillRef>
+            <a:effectRef idx="2">
+              <a:schemeClr val="accent1"/>
+            </a:effectRef>
+            <a:fontRef idx="minor">
+              <a:schemeClr val="lt1"/>
+            </a:fontRef>
+          </p:style>
+          <p:txBody>
+            <a:bodyPr rtlCol="0" anchor="ctr"/>
+            <a:lstStyle/>
+            <a:p>
+              <a:pPr algn="ctr"/>
+            </a:p>
+          </p:txBody>
+        </p:sp>
+        <p:sp>
+          <p:nvSpPr>
+            <p:cNvPr id="22" name="TextBox 21"/>
+            <p:cNvSpPr txBox="1"/>
+            <p:nvPr/>
+          </p:nvSpPr>
+          <p:spPr>
+            <a:xfrm>
+              <a:off x="9722920" y="2286423"/>
+              <a:ext cx="1051560" cy="155448"/>
+            </a:xfrm>
+            <a:prstGeom prst="rect">
+              <a:avLst/>
+            </a:prstGeom>
+            <a:noFill/>
+          </p:spPr>
+          <p:txBody>
+            <a:bodyPr wrap="none" lIns="0" rIns="0" tIns="0" bIns="0" anchor="ctr">
+              <a:spAutoFit/>
+            </a:bodyPr>
+            <a:lstStyle/>
+            <a:p>
+              <a:r>
+                <a:rPr sz="1000">
+                  <a:solidFill>
+                    <a:srgbClr val="000000"/>
+                  </a:solidFill>
+                  <a:latin typeface="Arial"/>
+                </a:rPr>
+                <a:t>MobileSAM (r=8)</a:t>
               </a:r>
             </a:p>
           </p:txBody>
@@ -13949,7 +13588,7 @@
                 </a:solidFill>
                 <a:latin typeface="Arial"/>
               </a:rPr>
-              <a:t>Panel image 1536 × 1536 px, upsampled 2× from the 768 × 768 px source array.</a:t>
+              <a:t>Panel image 1024 × 1024 px, upsampled 4× from the 256 × 256 px window (objects.json, FigS4).</a:t>
             </a:r>
           </a:p>
           <a:p>
@@ -13961,7 +13600,7 @@
                 </a:solidFill>
                 <a:latin typeface="Arial"/>
               </a:rPr>
-              <a:t>Pixel pitch 0.1441 μm/px, so one panel spans 768 × 0.1441 = 110.67 μm.</a:t>
+              <a:t>Pixel pitch 0.1441 μm/px, so one panel spans 256 × 0.1441 = 36.89 μm.</a:t>
             </a:r>
           </a:p>
           <a:p>
@@ -13985,7 +13624,7 @@
                 </a:solidFill>
                 <a:latin typeface="Arial"/>
               </a:rPr>
-              <a:t>Scale bar 20 μm = 20 / 110.67 = 18.07 % of panel width = 8.5178 × 0.1807 = 1.5393 cm.</a:t>
+              <a:t>Scale bar 20 μm = 20 / 36.89 = 54.2 % of panel width = 4.6180 cm.</a:t>
             </a:r>
           </a:p>
         </p:txBody>

</xml_diff>

<commit_message>
Fig. 1 readout formulas match Eqs. 7-10
A = N_Omega dx_eff^2 (pixel count of the domain, not N x Omega), S summed over i in Omega
with dx_eff, C and m unchanged; all four now in the same plain-text style; S labelled
"Integrated phase" as in the text and caption.

Co-Authored-By: Claude Opus 5.5 <noreply@anthropic.com>
Claude-Session: https://claude.ai/code/session_01VfeP9iXHsiwMyJPGSYpWbp
</commit_message>
<xml_diff>
--- a/artifacts/figures/pptx/Figures_revised.pptx
+++ b/artifacts/figures/pptx/Figures_revised.pptx
@@ -10357,213 +10357,119 @@
                 </a:p>
               </p:txBody>
             </p:sp>
-            <mc:AlternateContent xmlns:mc="http://schemas.openxmlformats.org/markup-compatibility/2006" xmlns:a14="http://schemas.microsoft.com/office/drawing/2010/main">
-              <mc:Choice Requires="a14">
-                <p:sp>
-                  <p:nvSpPr>
-                    <p:cNvPr id="226" name="TextBox 225"/>
-                    <p:cNvSpPr txBox="1"/>
-                    <p:nvPr/>
-                  </p:nvSpPr>
-                  <p:spPr>
-                    <a:xfrm>
-                      <a:off x="10108456" y="3477938"/>
-                      <a:ext cx="1578719" cy="184666"/>
-                    </a:xfrm>
-                    <a:prstGeom prst="rect">
-                      <a:avLst/>
-                    </a:prstGeom>
-                    <a:noFill/>
-                  </p:spPr>
-                  <p:txBody>
-                    <a:bodyPr wrap="square" lIns="0" tIns="0" rIns="0" bIns="0" anchor="ctr">
-                      <a:spAutoFit/>
-                    </a:bodyPr>
-                    <a:lstStyle/>
-                    <a:p>
-                      <a:pPr marL="171450" indent="-171450">
-                        <a:buClr>
-                          <a:srgbClr val="08275F"/>
-                        </a:buClr>
-                        <a:buFont typeface="Wingdings" panose="05000000000000000000" pitchFamily="2" charset="2"/>
-                        <a:buChar char="§"/>
-                      </a:pPr>
-                      <a14:m>
-                        <m:oMath xmlns:m="http://schemas.openxmlformats.org/officeDocument/2006/math">
-                          <m:r>
-                            <a:rPr lang="en-US" altLang="ko-KR" sz="1200" b="1" i="1" spc="-100" dirty="0" smtClean="0">
-                              <a:ln>
-                                <a:solidFill>
-                                  <a:schemeClr val="accent1">
-                                    <a:alpha val="0"/>
-                                  </a:schemeClr>
-                                </a:solidFill>
-                              </a:ln>
-                              <a:solidFill>
-                                <a:srgbClr val="08275F"/>
-                              </a:solidFill>
-                              <a:latin typeface="Cambria Math" panose="02040503050406030204" pitchFamily="18" charset="0"/>
-                            </a:rPr>
-                            <m:t>𝑨</m:t>
-                          </m:r>
-                          <m:r>
-                            <a:rPr lang="en-US" altLang="ko-KR" sz="1200" b="1" i="1" spc="-100" dirty="0" smtClean="0">
-                              <a:ln>
-                                <a:solidFill>
-                                  <a:schemeClr val="accent1">
-                                    <a:alpha val="0"/>
-                                  </a:schemeClr>
-                                </a:solidFill>
-                              </a:ln>
-                              <a:solidFill>
-                                <a:srgbClr val="08275F"/>
-                              </a:solidFill>
-                              <a:latin typeface="Cambria Math" panose="02040503050406030204" pitchFamily="18" charset="0"/>
-                            </a:rPr>
-                            <m:t> = </m:t>
-                          </m:r>
-                          <m:r>
-                            <a:rPr lang="en-US" altLang="ko-KR" sz="1200" b="1" i="1" spc="-100" dirty="0" smtClean="0">
-                              <a:ln>
-                                <a:solidFill>
-                                  <a:schemeClr val="accent1">
-                                    <a:alpha val="0"/>
-                                  </a:schemeClr>
-                                </a:solidFill>
-                              </a:ln>
-                              <a:solidFill>
-                                <a:srgbClr val="08275F"/>
-                              </a:solidFill>
-                              <a:latin typeface="Cambria Math" panose="02040503050406030204" pitchFamily="18" charset="0"/>
-                            </a:rPr>
-                            <m:t>𝑵</m:t>
-                          </m:r>
-                          <m:r>
-                            <a:rPr lang="el-GR" altLang="ko-KR" sz="1200" b="1" i="0" spc="-100" dirty="0" smtClean="0">
-                              <a:ln>
-                                <a:solidFill>
-                                  <a:schemeClr val="accent1">
-                                    <a:alpha val="0"/>
-                                  </a:schemeClr>
-                                </a:solidFill>
-                              </a:ln>
-                              <a:solidFill>
-                                <a:srgbClr val="08275F"/>
-                              </a:solidFill>
-                              <a:latin typeface="Cambria Math" panose="02040503050406030204" pitchFamily="18" charset="0"/>
-                            </a:rPr>
-                            <m:t>𝛀</m:t>
-                          </m:r>
-                          <m:r>
-                            <a:rPr lang="el-GR" altLang="ko-KR" sz="1200" b="1" i="1" spc="-100" dirty="0" smtClean="0">
-                              <a:ln>
-                                <a:solidFill>
-                                  <a:schemeClr val="accent1">
-                                    <a:alpha val="0"/>
-                                  </a:schemeClr>
-                                </a:solidFill>
-                              </a:ln>
-                              <a:solidFill>
-                                <a:srgbClr val="08275F"/>
-                              </a:solidFill>
-                              <a:latin typeface="Cambria Math" panose="02040503050406030204" pitchFamily="18" charset="0"/>
-                            </a:rPr>
-                            <m:t> · </m:t>
-                          </m:r>
-                          <m:r>
-                            <a:rPr lang="el-GR" altLang="ko-KR" sz="1200" b="1" i="0" spc="-100" dirty="0" smtClean="0">
-                              <a:ln>
-                                <a:solidFill>
-                                  <a:schemeClr val="accent1">
-                                    <a:alpha val="0"/>
-                                  </a:schemeClr>
-                                </a:solidFill>
-                              </a:ln>
-                              <a:solidFill>
-                                <a:srgbClr val="08275F"/>
-                              </a:solidFill>
-                              <a:latin typeface="Cambria Math" panose="02040503050406030204" pitchFamily="18" charset="0"/>
-                            </a:rPr>
-                            <m:t>𝚫</m:t>
-                          </m:r>
-                          <m:r>
-                            <a:rPr lang="en-US" altLang="ko-KR" sz="1200" b="1" i="1" spc="-100" dirty="0" smtClean="0">
-                              <a:ln>
-                                <a:solidFill>
-                                  <a:schemeClr val="accent1">
-                                    <a:alpha val="0"/>
-                                  </a:schemeClr>
-                                </a:solidFill>
-                              </a:ln>
-                              <a:solidFill>
-                                <a:srgbClr val="08275F"/>
-                              </a:solidFill>
-                              <a:latin typeface="Cambria Math" panose="02040503050406030204" pitchFamily="18" charset="0"/>
-                            </a:rPr>
-                            <m:t>𝒙</m:t>
-                          </m:r>
-                          <m:r>
-                            <a:rPr lang="en-US" altLang="ko-KR" sz="1200" b="1" i="1" spc="-100" dirty="0" smtClean="0">
-                              <a:ln>
-                                <a:solidFill>
-                                  <a:schemeClr val="accent1">
-                                    <a:alpha val="0"/>
-                                  </a:schemeClr>
-                                </a:solidFill>
-                              </a:ln>
-                              <a:solidFill>
-                                <a:srgbClr val="08275F"/>
-                              </a:solidFill>
-                              <a:latin typeface="Cambria Math" panose="02040503050406030204" pitchFamily="18" charset="0"/>
-                            </a:rPr>
-                            <m:t>²</m:t>
-                          </m:r>
-                        </m:oMath>
-                      </a14:m>
-                      <a:endParaRPr/>
-                    </a:p>
-                  </p:txBody>
-                </p:sp>
-              </mc:Choice>
-              <mc:Fallback xmlns="">
-                <p:sp>
-                  <p:nvSpPr>
-                    <p:cNvPr id="226" name="TextBox 225"/>
-                    <p:cNvSpPr txBox="1">
-                      <a:spLocks noRot="1" noChangeAspect="1" noMove="1" noResize="1" noEditPoints="1" noAdjustHandles="1" noChangeArrowheads="1" noChangeShapeType="1" noTextEdit="1"/>
-                    </p:cNvSpPr>
-                    <p:nvPr/>
-                  </p:nvSpPr>
-                  <p:spPr>
-                    <a:xfrm>
-                      <a:off x="10108456" y="3477938"/>
-                      <a:ext cx="1578719" cy="184666"/>
-                    </a:xfrm>
-                    <a:prstGeom prst="rect">
-                      <a:avLst/>
-                    </a:prstGeom>
-                    <a:blipFill>
-                      <a:blip r:embed="rId26"/>
-                      <a:stretch>
-                        <a:fillRect/>
-                      </a:stretch>
-                    </a:blipFill>
-                  </p:spPr>
-                  <p:txBody>
-                    <a:bodyPr/>
-                    <a:lstStyle/>
-                    <a:p>
-                      <a:r>
-                        <a:rPr lang="ko-KR" altLang="en-US">
-                          <a:noFill/>
-                        </a:rPr>
-                        <a:t> </a:t>
-                      </a:r>
-                    </a:p>
-                  </p:txBody>
-                </p:sp>
-              </mc:Fallback>
-            </mc:AlternateContent>
+            <p:sp xmlns:a14="http://schemas.microsoft.com/office/drawing/2010/main">
+              <p:nvSpPr>
+                <p:cNvPr id="226" name="TextBox 225"/>
+                <p:cNvSpPr txBox="1"/>
+                <p:nvPr/>
+              </p:nvSpPr>
+              <p:spPr>
+                <a:xfrm>
+                  <a:off x="10108456" y="3477938"/>
+                  <a:ext cx="1578719" cy="184666"/>
+                </a:xfrm>
+                <a:prstGeom prst="rect">
+                  <a:avLst/>
+                </a:prstGeom>
+                <a:noFill/>
+              </p:spPr>
+              <p:txBody>
+                <a:bodyPr wrap="square" lIns="0" tIns="0" rIns="0" bIns="0" anchor="ctr">
+                  <a:spAutoFit/>
+                </a:bodyPr>
+                <a:lstStyle/>
+                <a:p>
+                  <a:pPr marL="171450" indent="-171450">
+                    <a:buClr>
+                      <a:srgbClr val="08275F"/>
+                    </a:buClr>
+                    <a:buFont typeface="Wingdings" panose="05000000000000000000" pitchFamily="2" charset="2"/>
+                    <a:buChar char="§"/>
+                  </a:pPr>
+                  <a:r>
+                    <a:rPr lang="en-US" altLang="ko-KR" sz="1200" b="1" i="1" dirty="0" smtClean="0">
+                      <a:ln>
+                        <a:solidFill>
+                          <a:schemeClr val="accent1">
+                            <a:alpha val="0"/>
+                          </a:schemeClr>
+                        </a:solidFill>
+                      </a:ln>
+                      <a:solidFill>
+                        <a:srgbClr val="08275F"/>
+                      </a:solidFill>
+                      <a:latin typeface="Cambria Math" panose="02040503050406030204" pitchFamily="18" charset="0"/>
+                    </a:rPr>
+                    <a:t>𝑨 = 𝑵</a:t>
+                  </a:r>
+                  <a:r>
+                    <a:rPr lang="en-US" altLang="ko-KR" sz="1200" b="1" i="1" dirty="0" smtClean="0" baseline="-25000">
+                      <a:ln>
+                        <a:solidFill>
+                          <a:schemeClr val="accent1">
+                            <a:alpha val="0"/>
+                          </a:schemeClr>
+                        </a:solidFill>
+                      </a:ln>
+                      <a:solidFill>
+                        <a:srgbClr val="08275F"/>
+                      </a:solidFill>
+                      <a:latin typeface="Cambria Math" panose="02040503050406030204" pitchFamily="18" charset="0"/>
+                    </a:rPr>
+                    <a:t>Ω</a:t>
+                  </a:r>
+                  <a:r>
+                    <a:rPr lang="en-US" altLang="ko-KR" sz="1200" b="1" i="1" dirty="0" smtClean="0">
+                      <a:ln>
+                        <a:solidFill>
+                          <a:schemeClr val="accent1">
+                            <a:alpha val="0"/>
+                          </a:schemeClr>
+                        </a:solidFill>
+                      </a:ln>
+                      <a:solidFill>
+                        <a:srgbClr val="08275F"/>
+                      </a:solidFill>
+                      <a:latin typeface="Cambria Math" panose="02040503050406030204" pitchFamily="18" charset="0"/>
+                    </a:rPr>
+                    <a:t> · 𝚫𝒙</a:t>
+                  </a:r>
+                  <a:r>
+                    <a:rPr lang="en-US" altLang="ko-KR" sz="1200" b="1" i="1" dirty="0" smtClean="0" baseline="-25000">
+                      <a:ln>
+                        <a:solidFill>
+                          <a:schemeClr val="accent1">
+                            <a:alpha val="0"/>
+                          </a:schemeClr>
+                        </a:solidFill>
+                      </a:ln>
+                      <a:solidFill>
+                        <a:srgbClr val="08275F"/>
+                      </a:solidFill>
+                      <a:latin typeface="Cambria Math" panose="02040503050406030204" pitchFamily="18" charset="0"/>
+                    </a:rPr>
+                    <a:t>eff</a:t>
+                  </a:r>
+                  <a:r>
+                    <a:rPr lang="en-US" altLang="ko-KR" sz="1200" b="1" i="1" dirty="0" smtClean="0" baseline="30000">
+                      <a:ln>
+                        <a:solidFill>
+                          <a:schemeClr val="accent1">
+                            <a:alpha val="0"/>
+                          </a:schemeClr>
+                        </a:solidFill>
+                      </a:ln>
+                      <a:solidFill>
+                        <a:srgbClr val="08275F"/>
+                      </a:solidFill>
+                      <a:latin typeface="Cambria Math" panose="02040503050406030204" pitchFamily="18" charset="0"/>
+                    </a:rPr>
+                    <a:t>2</a:t>
+                  </a:r>
+                  <a:endParaRPr/>
+                </a:p>
+              </p:txBody>
+            </p:sp>
             <p:sp>
               <p:nvSpPr>
                 <p:cNvPr id="229" name="TextBox 228"/>
@@ -10756,213 +10662,71 @@
                 </a:p>
               </p:txBody>
             </p:sp>
-            <mc:AlternateContent xmlns:mc="http://schemas.openxmlformats.org/markup-compatibility/2006" xmlns:a14="http://schemas.microsoft.com/office/drawing/2010/main">
-              <mc:Choice Requires="a14">
-                <p:sp>
-                  <p:nvSpPr>
-                    <p:cNvPr id="233" name="TextBox 232"/>
-                    <p:cNvSpPr txBox="1"/>
-                    <p:nvPr/>
-                  </p:nvSpPr>
-                  <p:spPr>
-                    <a:xfrm>
-                      <a:off x="10108456" y="4129084"/>
-                      <a:ext cx="1159619" cy="184666"/>
-                    </a:xfrm>
-                    <a:prstGeom prst="rect">
-                      <a:avLst/>
-                    </a:prstGeom>
-                    <a:noFill/>
-                  </p:spPr>
-                  <p:txBody>
-                    <a:bodyPr wrap="square" lIns="0" tIns="0" rIns="0" bIns="0" anchor="ctr">
-                      <a:spAutoFit/>
-                    </a:bodyPr>
-                    <a:lstStyle/>
-                    <a:p>
-                      <a:pPr marL="171450" indent="-171450">
-                        <a:buClr>
-                          <a:srgbClr val="08275F"/>
-                        </a:buClr>
-                        <a:buFont typeface="Wingdings" panose="05000000000000000000" pitchFamily="2" charset="2"/>
-                        <a:buChar char="§"/>
-                      </a:pPr>
-                      <a14:m>
-                        <m:oMath xmlns:m="http://schemas.openxmlformats.org/officeDocument/2006/math">
-                          <m:r>
-                            <a:rPr lang="en-US" altLang="ko-KR" sz="1200" b="1" i="1" spc="-100" dirty="0" smtClean="0">
-                              <a:ln>
-                                <a:solidFill>
-                                  <a:schemeClr val="accent1">
-                                    <a:alpha val="0"/>
-                                  </a:schemeClr>
-                                </a:solidFill>
-                              </a:ln>
-                              <a:solidFill>
-                                <a:srgbClr val="08275F"/>
-                              </a:solidFill>
-                              <a:latin typeface="Cambria Math" panose="02040503050406030204" pitchFamily="18" charset="0"/>
-                            </a:rPr>
-                            <m:t>𝑪</m:t>
-                          </m:r>
-                          <m:r>
-                            <a:rPr lang="en-US" altLang="ko-KR" sz="1200" b="1" i="1" spc="-100" dirty="0" smtClean="0">
-                              <a:ln>
-                                <a:solidFill>
-                                  <a:schemeClr val="accent1">
-                                    <a:alpha val="0"/>
-                                  </a:schemeClr>
-                                </a:solidFill>
-                              </a:ln>
-                              <a:solidFill>
-                                <a:srgbClr val="08275F"/>
-                              </a:solidFill>
-                              <a:latin typeface="Cambria Math" panose="02040503050406030204" pitchFamily="18" charset="0"/>
-                            </a:rPr>
-                            <m:t> = </m:t>
-                          </m:r>
-                          <m:r>
-                            <a:rPr lang="en-US" altLang="ko-KR" sz="1200" b="1" i="1" spc="-100" dirty="0" smtClean="0">
-                              <a:ln>
-                                <a:solidFill>
-                                  <a:schemeClr val="accent1">
-                                    <a:alpha val="0"/>
-                                  </a:schemeClr>
-                                </a:solidFill>
-                              </a:ln>
-                              <a:solidFill>
-                                <a:srgbClr val="08275F"/>
-                              </a:solidFill>
-                              <a:latin typeface="Cambria Math" panose="02040503050406030204" pitchFamily="18" charset="0"/>
-                            </a:rPr>
-                            <m:t>𝟒</m:t>
-                          </m:r>
-                          <m:r>
-                            <a:rPr lang="el-GR" altLang="ko-KR" sz="1200" b="1" i="1" spc="-100" dirty="0" smtClean="0">
-                              <a:ln>
-                                <a:solidFill>
-                                  <a:schemeClr val="accent1">
-                                    <a:alpha val="0"/>
-                                  </a:schemeClr>
-                                </a:solidFill>
-                              </a:ln>
-                              <a:solidFill>
-                                <a:srgbClr val="08275F"/>
-                              </a:solidFill>
-                              <a:latin typeface="Cambria Math" panose="02040503050406030204" pitchFamily="18" charset="0"/>
-                            </a:rPr>
-                            <m:t>𝝅</m:t>
-                          </m:r>
-                          <m:r>
-                            <a:rPr lang="en-US" altLang="ko-KR" sz="1200" b="1" i="1" spc="-100" dirty="0" smtClean="0">
-                              <a:ln>
-                                <a:solidFill>
-                                  <a:schemeClr val="accent1">
-                                    <a:alpha val="0"/>
-                                  </a:schemeClr>
-                                </a:solidFill>
-                              </a:ln>
-                              <a:solidFill>
-                                <a:srgbClr val="08275F"/>
-                              </a:solidFill>
-                              <a:latin typeface="Cambria Math" panose="02040503050406030204" pitchFamily="18" charset="0"/>
-                            </a:rPr>
-                            <m:t>𝑨</m:t>
-                          </m:r>
-                          <m:r>
-                            <a:rPr lang="en-US" altLang="ko-KR" sz="1200" b="1" i="1" spc="-100" dirty="0" smtClean="0">
-                              <a:ln>
-                                <a:solidFill>
-                                  <a:schemeClr val="accent1">
-                                    <a:alpha val="0"/>
-                                  </a:schemeClr>
-                                </a:solidFill>
-                              </a:ln>
-                              <a:solidFill>
-                                <a:srgbClr val="08275F"/>
-                              </a:solidFill>
-                              <a:latin typeface="Cambria Math" panose="02040503050406030204" pitchFamily="18" charset="0"/>
-                            </a:rPr>
-                            <m:t> / </m:t>
-                          </m:r>
-                          <m:r>
-                            <a:rPr lang="en-US" altLang="ko-KR" sz="1200" b="1" i="1" spc="-100" dirty="0" smtClean="0">
-                              <a:ln>
-                                <a:solidFill>
-                                  <a:schemeClr val="accent1">
-                                    <a:alpha val="0"/>
-                                  </a:schemeClr>
-                                </a:solidFill>
-                              </a:ln>
-                              <a:solidFill>
-                                <a:srgbClr val="08275F"/>
-                              </a:solidFill>
-                              <a:latin typeface="Cambria Math" panose="02040503050406030204" pitchFamily="18" charset="0"/>
-                            </a:rPr>
-                            <m:t>𝑷</m:t>
-                          </m:r>
-                          <m:r>
-                            <a:rPr lang="en-US" altLang="ko-KR" sz="1200" b="1" i="1" spc="-100" dirty="0" smtClean="0">
-                              <a:ln>
-                                <a:solidFill>
-                                  <a:schemeClr val="accent1">
-                                    <a:alpha val="0"/>
-                                  </a:schemeClr>
-                                </a:solidFill>
-                              </a:ln>
-                              <a:solidFill>
-                                <a:srgbClr val="08275F"/>
-                              </a:solidFill>
-                              <a:latin typeface="Cambria Math" panose="02040503050406030204" pitchFamily="18" charset="0"/>
-                            </a:rPr>
-                            <m:t>²</m:t>
-                          </m:r>
-                        </m:oMath>
-                      </a14:m>
-                      <a:endParaRPr/>
-                    </a:p>
-                  </p:txBody>
-                </p:sp>
-              </mc:Choice>
-              <mc:Fallback xmlns="">
-                <p:sp>
-                  <p:nvSpPr>
-                    <p:cNvPr id="233" name="TextBox 232"/>
-                    <p:cNvSpPr txBox="1">
-                      <a:spLocks noRot="1" noChangeAspect="1" noMove="1" noResize="1" noEditPoints="1" noAdjustHandles="1" noChangeArrowheads="1" noChangeShapeType="1" noTextEdit="1"/>
-                    </p:cNvSpPr>
-                    <p:nvPr/>
-                  </p:nvSpPr>
-                  <p:spPr>
-                    <a:xfrm>
-                      <a:off x="10108456" y="4129084"/>
-                      <a:ext cx="1159619" cy="184666"/>
-                    </a:xfrm>
-                    <a:prstGeom prst="rect">
-                      <a:avLst/>
-                    </a:prstGeom>
-                    <a:blipFill>
-                      <a:blip r:embed="rId27"/>
-                      <a:stretch>
-                        <a:fillRect/>
-                      </a:stretch>
-                    </a:blipFill>
-                  </p:spPr>
-                  <p:txBody>
-                    <a:bodyPr/>
-                    <a:lstStyle/>
-                    <a:p>
-                      <a:r>
-                        <a:rPr lang="ko-KR" altLang="en-US">
-                          <a:noFill/>
-                        </a:rPr>
-                        <a:t> </a:t>
-                      </a:r>
-                    </a:p>
-                  </p:txBody>
-                </p:sp>
-              </mc:Fallback>
-            </mc:AlternateContent>
+            <p:sp xmlns:a14="http://schemas.microsoft.com/office/drawing/2010/main">
+              <p:nvSpPr>
+                <p:cNvPr id="233" name="TextBox 232"/>
+                <p:cNvSpPr txBox="1"/>
+                <p:nvPr/>
+              </p:nvSpPr>
+              <p:spPr>
+                <a:xfrm>
+                  <a:off x="10108456" y="4129084"/>
+                  <a:ext cx="1159619" cy="184666"/>
+                </a:xfrm>
+                <a:prstGeom prst="rect">
+                  <a:avLst/>
+                </a:prstGeom>
+                <a:noFill/>
+              </p:spPr>
+              <p:txBody>
+                <a:bodyPr wrap="square" lIns="0" tIns="0" rIns="0" bIns="0" anchor="ctr">
+                  <a:spAutoFit/>
+                </a:bodyPr>
+                <a:lstStyle/>
+                <a:p>
+                  <a:pPr marL="171450" indent="-171450">
+                    <a:buClr>
+                      <a:srgbClr val="08275F"/>
+                    </a:buClr>
+                    <a:buFont typeface="Wingdings" panose="05000000000000000000" pitchFamily="2" charset="2"/>
+                    <a:buChar char="§"/>
+                  </a:pPr>
+                  <a:r>
+                    <a:rPr lang="en-US" altLang="ko-KR" sz="1200" b="1" i="1" dirty="0" smtClean="0">
+                      <a:ln>
+                        <a:solidFill>
+                          <a:schemeClr val="accent1">
+                            <a:alpha val="0"/>
+                          </a:schemeClr>
+                        </a:solidFill>
+                      </a:ln>
+                      <a:solidFill>
+                        <a:srgbClr val="08275F"/>
+                      </a:solidFill>
+                      <a:latin typeface="Cambria Math" panose="02040503050406030204" pitchFamily="18" charset="0"/>
+                    </a:rPr>
+                    <a:t>𝑪 = 𝟒𝝅𝑨 / 𝑷</a:t>
+                  </a:r>
+                  <a:r>
+                    <a:rPr lang="en-US" altLang="ko-KR" sz="1200" b="1" i="1" dirty="0" smtClean="0" baseline="30000">
+                      <a:ln>
+                        <a:solidFill>
+                          <a:schemeClr val="accent1">
+                            <a:alpha val="0"/>
+                          </a:schemeClr>
+                        </a:solidFill>
+                      </a:ln>
+                      <a:solidFill>
+                        <a:srgbClr val="08275F"/>
+                      </a:solidFill>
+                      <a:latin typeface="Cambria Math" panose="02040503050406030204" pitchFamily="18" charset="0"/>
+                    </a:rPr>
+                    <a:t>2</a:t>
+                  </a:r>
+                  <a:endParaRPr/>
+                </a:p>
+              </p:txBody>
+            </p:sp>
             <p:sp>
               <p:nvSpPr>
                 <p:cNvPr id="234" name="TextBox 233"/>
@@ -11121,7 +10885,7 @@
               <p:spPr>
                 <a:xfrm>
                   <a:off x="10108456" y="4780432"/>
-                  <a:ext cx="1518394" cy="184666"/>
+                  <a:ext cx="1737360" cy="184666"/>
                 </a:xfrm>
                 <a:prstGeom prst="rect">
                   <a:avLst/>
@@ -11155,7 +10919,39 @@
                       </a:solidFill>
                       <a:latin typeface="Cambria Math" panose="02040503050406030204" pitchFamily="18" charset="0"/>
                     </a:rPr>
-                    <a:t>𝑺 = 𝚺(𝝓</a:t>
+                    <a:t>𝑺 = 𝚺</a:t>
+                  </a:r>
+                  <a:r>
+                    <a:rPr lang="en-US" altLang="ko-KR" sz="1200" b="1" i="1" dirty="0" smtClean="0" baseline="-25000">
+                      <a:ln>
+                        <a:solidFill>
+                          <a:schemeClr val="accent1">
+                            <a:alpha val="0"/>
+                          </a:schemeClr>
+                        </a:solidFill>
+                      </a:ln>
+                      <a:solidFill>
+                        <a:srgbClr val="08275F"/>
+                      </a:solidFill>
+                      <a:latin typeface="Cambria Math" panose="02040503050406030204" pitchFamily="18" charset="0"/>
+                    </a:rPr>
+                    <a:t>i∈Ω</a:t>
+                  </a:r>
+                  <a:r>
+                    <a:rPr lang="en-US" altLang="ko-KR" sz="1200" b="1" i="1" dirty="0" smtClean="0">
+                      <a:ln>
+                        <a:solidFill>
+                          <a:schemeClr val="accent1">
+                            <a:alpha val="0"/>
+                          </a:schemeClr>
+                        </a:solidFill>
+                      </a:ln>
+                      <a:solidFill>
+                        <a:srgbClr val="08275F"/>
+                      </a:solidFill>
+                      <a:latin typeface="Cambria Math" panose="02040503050406030204" pitchFamily="18" charset="0"/>
+                    </a:rPr>
+                    <a:t>(𝝓</a:t>
                   </a:r>
                   <a:r>
                     <a:rPr lang="en-US" altLang="ko-KR" sz="1200" b="1" i="1" dirty="0" smtClean="0" baseline="-25000">
@@ -11187,7 +10983,7 @@
                       </a:solidFill>
                       <a:latin typeface="Cambria Math" panose="02040503050406030204" pitchFamily="18" charset="0"/>
                     </a:rPr>
-                    <a:t> − 𝝓</a:t>
+                    <a:t>−𝝓</a:t>
                   </a:r>
                   <a:r>
                     <a:rPr lang="en-US" altLang="ko-KR" sz="1200" b="1" i="1" dirty="0" smtClean="0" baseline="-25000">
@@ -11219,7 +11015,23 @@
                       </a:solidFill>
                       <a:latin typeface="Cambria Math" panose="02040503050406030204" pitchFamily="18" charset="0"/>
                     </a:rPr>
-                    <a:t>) · 𝚫𝒙</a:t>
+                    <a:t>)·𝚫𝒙</a:t>
+                  </a:r>
+                  <a:r>
+                    <a:rPr lang="en-US" altLang="ko-KR" sz="1200" b="1" i="1" dirty="0" smtClean="0" baseline="-25000">
+                      <a:ln>
+                        <a:solidFill>
+                          <a:schemeClr val="accent1">
+                            <a:alpha val="0"/>
+                          </a:schemeClr>
+                        </a:solidFill>
+                      </a:ln>
+                      <a:solidFill>
+                        <a:srgbClr val="08275F"/>
+                      </a:solidFill>
+                      <a:latin typeface="Cambria Math" panose="02040503050406030204" pitchFamily="18" charset="0"/>
+                    </a:rPr>
+                    <a:t>eff</a:t>
                   </a:r>
                   <a:r>
                     <a:rPr lang="en-US" altLang="ko-KR" sz="1200" b="1" i="1" dirty="0" smtClean="0" baseline="30000">
@@ -11289,7 +11101,7 @@
                       </a:solidFill>
                       <a:latin typeface="Arial"/>
                     </a:rPr>
-                    <a:t>Phase-integrated</a:t>
+                    <a:t>Integrated phase</a:t>
                   </a:r>
                   <a:br>
                     <a:rPr lang="en-US" sz="950" i="1" dirty="0">
@@ -11309,25 +11121,6 @@
                       <a:latin typeface="Arial"/>
                     </a:rPr>
                   </a:br>
-                  <a:r>
-                    <a:rPr lang="en-US" sz="950" i="1" dirty="0">
-                      <a:ln>
-                        <a:solidFill>
-                          <a:schemeClr val="accent1">
-                            <a:alpha val="0"/>
-                          </a:schemeClr>
-                        </a:solidFill>
-                      </a:ln>
-                      <a:solidFill>
-                        <a:schemeClr val="tx1">
-                          <a:lumMod val="75000"/>
-                          <a:lumOff val="25000"/>
-                        </a:schemeClr>
-                      </a:solidFill>
-                      <a:latin typeface="Arial"/>
-                    </a:rPr>
-                    <a:t>optical quantity</a:t>
-                  </a:r>
                 </a:p>
               </p:txBody>
             </p:sp>

</xml_diff>